<commit_message>
restaura conteúdo da versão anterior na apresentação
- slide 5: subtítulo destaca explicitamente a variação de Dijkstra
  utilizada (uma execução, com anotação extra por vértice)
- slide 7: observação-chave volta à forma completa (vértices que não
  são destino de trem caem no Dijkstra padrão)
- slide 7: adiciona o 4º caso "y < dist[s] → impossível" como card
  próprio, completando a tipologia de decisões
</commit_message>
<xml_diff>
--- a/apresentacao/apresentacao.pptx
+++ b/apresentacao/apresentacao.pptx
@@ -7709,17 +7709,59 @@
               <a:buNone/>
             </a:pPr>
             <a:r>
-              <a:rPr lang="en-US" sz="1400" i="1" dirty="0">
-                <a:solidFill>
-                  <a:srgbClr val="8A93B8"/>
+              <a:rPr lang="en-US" sz="1300" b="1" dirty="0">
+                <a:solidFill>
+                  <a:srgbClr val="F96167"/>
                 </a:solidFill>
                 <a:latin typeface="Calibri" pitchFamily="34" charset="0"/>
                 <a:ea typeface="Calibri" pitchFamily="34" charset="-122"/>
                 <a:cs typeface="Calibri" pitchFamily="34" charset="-120"/>
               </a:rPr>
-              <a:t>Variação utilizada: Dijkstra clássico de origem única, com uma anotação por vértice.</a:t>
-            </a:r>
-            <a:endParaRPr lang="en-US" sz="1400" dirty="0"/>
+              <a:t>Variação de Dijkstra:  </a:t>
+            </a:r>
+            <a:pPr indent="0" marL="0">
+              <a:buNone/>
+            </a:pPr>
+            <a:r>
+              <a:rPr lang="en-US" sz="1300" i="1" dirty="0">
+                <a:solidFill>
+                  <a:srgbClr val="8A93B8"/>
+                </a:solidFill>
+                <a:latin typeface="Calibri" pitchFamily="34" charset="0"/>
+                <a:ea typeface="Calibri" pitchFamily="34" charset="-122"/>
+                <a:cs typeface="Calibri" pitchFamily="34" charset="-120"/>
+              </a:rPr>
+              <a:t>uma única execução do Dijkstra clássico de origem única, com uma anotação extra por vértice (</a:t>
+            </a:r>
+            <a:pPr indent="0" marL="0">
+              <a:buNone/>
+            </a:pPr>
+            <a:r>
+              <a:rPr lang="en-US" sz="1300" b="1" i="1" dirty="0">
+                <a:solidFill>
+                  <a:srgbClr val="1E2761"/>
+                </a:solidFill>
+                <a:latin typeface="Calibri" pitchFamily="34" charset="0"/>
+                <a:ea typeface="Calibri" pitchFamily="34" charset="-122"/>
+                <a:cs typeface="Calibri" pitchFamily="34" charset="-120"/>
+              </a:rPr>
+              <a:t>via_estrada</a:t>
+            </a:r>
+            <a:pPr indent="0" marL="0">
+              <a:buNone/>
+            </a:pPr>
+            <a:r>
+              <a:rPr lang="en-US" sz="1300" i="1" dirty="0">
+                <a:solidFill>
+                  <a:srgbClr val="8A93B8"/>
+                </a:solidFill>
+                <a:latin typeface="Calibri" pitchFamily="34" charset="0"/>
+                <a:ea typeface="Calibri" pitchFamily="34" charset="-122"/>
+                <a:cs typeface="Calibri" pitchFamily="34" charset="-120"/>
+              </a:rPr>
+              <a:t>) — sem expansão de estado nem múltiplas execuções.</a:t>
+            </a:r>
+            <a:endParaRPr lang="en-US" sz="1300" dirty="0"/>
           </a:p>
         </p:txBody>
       </p:sp>
@@ -11394,7 +11436,7 @@
               <a:buNone/>
             </a:pPr>
             <a:r>
-              <a:rPr lang="en-US" sz="1400" b="1" dirty="0">
+              <a:rPr lang="en-US" sz="1300" b="1" dirty="0">
                 <a:solidFill>
                   <a:srgbClr val="F96167"/>
                 </a:solidFill>
@@ -11408,7 +11450,7 @@
               <a:buNone/>
             </a:pPr>
             <a:r>
-              <a:rPr lang="en-US" sz="1400" dirty="0">
+              <a:rPr lang="en-US" sz="1300" dirty="0">
                 <a:solidFill>
                   <a:srgbClr val="0F1638"/>
                 </a:solidFill>
@@ -11416,13 +11458,13 @@
                 <a:ea typeface="Calibri" pitchFamily="34" charset="-122"/>
                 <a:cs typeface="Calibri" pitchFamily="34" charset="-120"/>
               </a:rPr>
-              <a:t>todo trem sai da capital, então em qualquer caminho mínimo um trem aparece como </a:t>
-            </a:r>
-            <a:pPr indent="0" marL="0">
-              <a:buNone/>
-            </a:pPr>
-            <a:r>
-              <a:rPr lang="en-US" sz="1400" b="1" dirty="0">
+              <a:t>todo trem sai da capital, então em qualquer caminho mínimo um trem só pode aparecer como </a:t>
+            </a:r>
+            <a:pPr indent="0" marL="0">
+              <a:buNone/>
+            </a:pPr>
+            <a:r>
+              <a:rPr lang="en-US" sz="1300" b="1" dirty="0">
                 <a:solidFill>
                   <a:srgbClr val="1E2761"/>
                 </a:solidFill>
@@ -11436,7 +11478,7 @@
               <a:buNone/>
             </a:pPr>
             <a:r>
-              <a:rPr lang="en-US" sz="1400" dirty="0">
+              <a:rPr lang="en-US" sz="1300" dirty="0">
                 <a:solidFill>
                   <a:srgbClr val="0F1638"/>
                 </a:solidFill>
@@ -11444,9 +11486,9 @@
                 <a:ea typeface="Calibri" pitchFamily="34" charset="-122"/>
                 <a:cs typeface="Calibri" pitchFamily="34" charset="-120"/>
               </a:rPr>
-              <a:t>. Decidimos um trem por vez, agrupados pela cidade de destino.</a:t>
-            </a:r>
-            <a:endParaRPr lang="en-US" sz="1400" dirty="0"/>
+              <a:t>. Para vértices que não são destino direto de trem o problema é Dijkstra padrão — basta decidir, para cada trem, se ele pode ser fechado.</a:t>
+            </a:r>
+            <a:endParaRPr lang="en-US" sz="1300" dirty="0"/>
           </a:p>
         </p:txBody>
       </p:sp>
@@ -11459,7 +11501,7 @@
         <p:spPr>
           <a:xfrm>
             <a:off x="457200" y="2240280"/>
-            <a:ext cx="3712464" cy="2743200"/>
+            <a:ext cx="2761488" cy="2743200"/>
           </a:xfrm>
           <a:prstGeom prst="roundRect">
             <a:avLst>
@@ -11485,24 +11527,24 @@
         </p:nvSpPr>
         <p:spPr>
           <a:xfrm>
-            <a:off x="685800" y="2331720"/>
-            <a:ext cx="3291840" cy="411480"/>
-          </a:xfrm>
-          <a:prstGeom prst="rect">
-            <a:avLst/>
-          </a:prstGeom>
-          <a:noFill/>
-          <a:ln/>
-        </p:spPr>
-        <p:txBody>
-          <a:bodyPr wrap="square" rtlCol="0" anchor="ctr"/>
-          <a:lstStyle/>
-          <a:p>
-            <a:pPr indent="0" marL="0">
-              <a:buNone/>
-            </a:pPr>
-            <a:r>
-              <a:rPr lang="en-US" sz="1600" b="1" dirty="0">
+            <a:off x="640080" y="2331720"/>
+            <a:ext cx="2395728" cy="365760"/>
+          </a:xfrm>
+          <a:prstGeom prst="rect">
+            <a:avLst/>
+          </a:prstGeom>
+          <a:noFill/>
+          <a:ln/>
+        </p:spPr>
+        <p:txBody>
+          <a:bodyPr wrap="square" rtlCol="0" anchor="ctr"/>
+          <a:lstStyle/>
+          <a:p>
+            <a:pPr indent="0" marL="0">
+              <a:buNone/>
+            </a:pPr>
+            <a:r>
+              <a:rPr lang="en-US" sz="1400" b="1" dirty="0">
                 <a:solidFill>
                   <a:srgbClr val="F96167"/>
                 </a:solidFill>
@@ -11512,7 +11554,7 @@
               </a:rPr>
               <a:t>Trem inútil</a:t>
             </a:r>
-            <a:endParaRPr lang="en-US" sz="1600" dirty="0"/>
+            <a:endParaRPr lang="en-US" sz="1400" dirty="0"/>
           </a:p>
         </p:txBody>
       </p:sp>
@@ -11524,24 +11566,24 @@
         </p:nvSpPr>
         <p:spPr>
           <a:xfrm>
-            <a:off x="685800" y="2788920"/>
-            <a:ext cx="3291840" cy="365760"/>
-          </a:xfrm>
-          <a:prstGeom prst="rect">
-            <a:avLst/>
-          </a:prstGeom>
-          <a:noFill/>
-          <a:ln/>
-        </p:spPr>
-        <p:txBody>
-          <a:bodyPr wrap="square" rtlCol="0" anchor="ctr"/>
-          <a:lstStyle/>
-          <a:p>
-            <a:pPr indent="0" marL="0">
-              <a:buNone/>
-            </a:pPr>
-            <a:r>
-              <a:rPr lang="en-US" sz="1200" dirty="0">
+            <a:off x="640080" y="2743200"/>
+            <a:ext cx="2395728" cy="365760"/>
+          </a:xfrm>
+          <a:prstGeom prst="rect">
+            <a:avLst/>
+          </a:prstGeom>
+          <a:noFill/>
+          <a:ln/>
+        </p:spPr>
+        <p:txBody>
+          <a:bodyPr wrap="square" rtlCol="0" anchor="ctr"/>
+          <a:lstStyle/>
+          <a:p>
+            <a:pPr indent="0" marL="0">
+              <a:buNone/>
+            </a:pPr>
+            <a:r>
+              <a:rPr lang="en-US" sz="1100" dirty="0">
                 <a:solidFill>
                   <a:srgbClr val="FFFFFF"/>
                 </a:solidFill>
@@ -11551,7 +11593,7 @@
               </a:rPr>
               <a:t>y &gt; dist[s]</a:t>
             </a:r>
-            <a:endParaRPr lang="en-US" sz="1200" dirty="0"/>
+            <a:endParaRPr lang="en-US" sz="1100" dirty="0"/>
           </a:p>
         </p:txBody>
       </p:sp>
@@ -11563,8 +11605,8 @@
         </p:nvSpPr>
         <p:spPr>
           <a:xfrm>
-            <a:off x="685800" y="3246120"/>
-            <a:ext cx="3291840" cy="0"/>
+            <a:off x="640080" y="3200400"/>
+            <a:ext cx="2395728" cy="0"/>
           </a:xfrm>
           <a:prstGeom prst="line">
             <a:avLst/>
@@ -11586,24 +11628,24 @@
         </p:nvSpPr>
         <p:spPr>
           <a:xfrm>
-            <a:off x="685800" y="3337560"/>
-            <a:ext cx="3291840" cy="365760"/>
-          </a:xfrm>
-          <a:prstGeom prst="rect">
-            <a:avLst/>
-          </a:prstGeom>
-          <a:noFill/>
-          <a:ln/>
-        </p:spPr>
-        <p:txBody>
-          <a:bodyPr wrap="square" rtlCol="0" anchor="ctr"/>
-          <a:lstStyle/>
-          <a:p>
-            <a:pPr indent="0" marL="0">
-              <a:buNone/>
-            </a:pPr>
-            <a:r>
-              <a:rPr lang="en-US" sz="1300" b="1" dirty="0">
+            <a:off x="640080" y="3291840"/>
+            <a:ext cx="2395728" cy="365760"/>
+          </a:xfrm>
+          <a:prstGeom prst="rect">
+            <a:avLst/>
+          </a:prstGeom>
+          <a:noFill/>
+          <a:ln/>
+        </p:spPr>
+        <p:txBody>
+          <a:bodyPr wrap="square" rtlCol="0" anchor="ctr"/>
+          <a:lstStyle/>
+          <a:p>
+            <a:pPr indent="0" marL="0">
+              <a:buNone/>
+            </a:pPr>
+            <a:r>
+              <a:rPr lang="en-US" sz="1200" b="1" dirty="0">
                 <a:solidFill>
                   <a:srgbClr val="F96167"/>
                 </a:solidFill>
@@ -11613,7 +11655,7 @@
               </a:rPr>
               <a:t>→ FECHA</a:t>
             </a:r>
-            <a:endParaRPr lang="en-US" sz="1300" dirty="0"/>
+            <a:endParaRPr lang="en-US" sz="1200" dirty="0"/>
           </a:p>
         </p:txBody>
       </p:sp>
@@ -11625,24 +11667,24 @@
         </p:nvSpPr>
         <p:spPr>
           <a:xfrm>
-            <a:off x="685800" y="3749040"/>
-            <a:ext cx="3291840" cy="1188720"/>
-          </a:xfrm>
-          <a:prstGeom prst="rect">
-            <a:avLst/>
-          </a:prstGeom>
-          <a:noFill/>
-          <a:ln/>
-        </p:spPr>
-        <p:txBody>
-          <a:bodyPr wrap="square" rtlCol="0" anchor="ctr"/>
-          <a:lstStyle/>
-          <a:p>
-            <a:pPr indent="0" marL="0">
-              <a:buNone/>
-            </a:pPr>
-            <a:r>
-              <a:rPr lang="en-US" sz="1200" dirty="0">
+            <a:off x="640080" y="3703320"/>
+            <a:ext cx="2395728" cy="1234440"/>
+          </a:xfrm>
+          <a:prstGeom prst="rect">
+            <a:avLst/>
+          </a:prstGeom>
+          <a:noFill/>
+          <a:ln/>
+        </p:spPr>
+        <p:txBody>
+          <a:bodyPr wrap="square" rtlCol="0" anchor="ctr"/>
+          <a:lstStyle/>
+          <a:p>
+            <a:pPr indent="0" marL="0">
+              <a:buNone/>
+            </a:pPr>
+            <a:r>
+              <a:rPr lang="en-US" sz="1100" dirty="0">
                 <a:solidFill>
                   <a:srgbClr val="CADCFC"/>
                 </a:solidFill>
@@ -11650,9 +11692,9 @@
                 <a:ea typeface="Calibri" pitchFamily="34" charset="-122"/>
                 <a:cs typeface="Calibri" pitchFamily="34" charset="-120"/>
               </a:rPr>
-              <a:t>O melhor caminho até s já é menor que o trem; fechar não muda nada.</a:t>
-            </a:r>
-            <a:endParaRPr lang="en-US" sz="1200" dirty="0"/>
+              <a:t>O melhor caminho até s já é menor que o trem.</a:t>
+            </a:r>
+            <a:endParaRPr lang="en-US" sz="1100" dirty="0"/>
           </a:p>
         </p:txBody>
       </p:sp>
@@ -11664,8 +11706,8 @@
         </p:nvSpPr>
         <p:spPr>
           <a:xfrm>
-            <a:off x="4361688" y="2240280"/>
-            <a:ext cx="3712464" cy="2743200"/>
+            <a:off x="3291840" y="2240280"/>
+            <a:ext cx="2761488" cy="2743200"/>
           </a:xfrm>
           <a:prstGeom prst="roundRect">
             <a:avLst>
@@ -11691,24 +11733,24 @@
         </p:nvSpPr>
         <p:spPr>
           <a:xfrm>
-            <a:off x="4590288" y="2331720"/>
-            <a:ext cx="3291840" cy="411480"/>
-          </a:xfrm>
-          <a:prstGeom prst="rect">
-            <a:avLst/>
-          </a:prstGeom>
-          <a:noFill/>
-          <a:ln/>
-        </p:spPr>
-        <p:txBody>
-          <a:bodyPr wrap="square" rtlCol="0" anchor="ctr"/>
-          <a:lstStyle/>
-          <a:p>
-            <a:pPr indent="0" marL="0">
-              <a:buNone/>
-            </a:pPr>
-            <a:r>
-              <a:rPr lang="en-US" sz="1600" b="1" dirty="0">
+            <a:off x="3474720" y="2331720"/>
+            <a:ext cx="2395728" cy="365760"/>
+          </a:xfrm>
+          <a:prstGeom prst="rect">
+            <a:avLst/>
+          </a:prstGeom>
+          <a:noFill/>
+          <a:ln/>
+        </p:spPr>
+        <p:txBody>
+          <a:bodyPr wrap="square" rtlCol="0" anchor="ctr"/>
+          <a:lstStyle/>
+          <a:p>
+            <a:pPr indent="0" marL="0">
+              <a:buNone/>
+            </a:pPr>
+            <a:r>
+              <a:rPr lang="en-US" sz="1400" b="1" dirty="0">
                 <a:solidFill>
                   <a:srgbClr val="CADCFC"/>
                 </a:solidFill>
@@ -11718,7 +11760,7 @@
               </a:rPr>
               <a:t>Alternativa por estrada</a:t>
             </a:r>
-            <a:endParaRPr lang="en-US" sz="1600" dirty="0"/>
+            <a:endParaRPr lang="en-US" sz="1400" dirty="0"/>
           </a:p>
         </p:txBody>
       </p:sp>
@@ -11730,24 +11772,24 @@
         </p:nvSpPr>
         <p:spPr>
           <a:xfrm>
-            <a:off x="4590288" y="2788920"/>
-            <a:ext cx="3291840" cy="365760"/>
-          </a:xfrm>
-          <a:prstGeom prst="rect">
-            <a:avLst/>
-          </a:prstGeom>
-          <a:noFill/>
-          <a:ln/>
-        </p:spPr>
-        <p:txBody>
-          <a:bodyPr wrap="square" rtlCol="0" anchor="ctr"/>
-          <a:lstStyle/>
-          <a:p>
-            <a:pPr indent="0" marL="0">
-              <a:buNone/>
-            </a:pPr>
-            <a:r>
-              <a:rPr lang="en-US" sz="1200" dirty="0">
+            <a:off x="3474720" y="2743200"/>
+            <a:ext cx="2395728" cy="365760"/>
+          </a:xfrm>
+          <a:prstGeom prst="rect">
+            <a:avLst/>
+          </a:prstGeom>
+          <a:noFill/>
+          <a:ln/>
+        </p:spPr>
+        <p:txBody>
+          <a:bodyPr wrap="square" rtlCol="0" anchor="ctr"/>
+          <a:lstStyle/>
+          <a:p>
+            <a:pPr indent="0" marL="0">
+              <a:buNone/>
+            </a:pPr>
+            <a:r>
+              <a:rPr lang="en-US" sz="1100" dirty="0">
                 <a:solidFill>
                   <a:srgbClr val="FFFFFF"/>
                 </a:solidFill>
@@ -11755,9 +11797,9 @@
                 <a:ea typeface="Consolas" pitchFamily="34" charset="-122"/>
                 <a:cs typeface="Consolas" pitchFamily="34" charset="-120"/>
               </a:rPr>
-              <a:t>y = dist[s]  e  via_estrada[s]</a:t>
-            </a:r>
-            <a:endParaRPr lang="en-US" sz="1200" dirty="0"/>
+              <a:t>y = dist[s] e via_estrada[s]</a:t>
+            </a:r>
+            <a:endParaRPr lang="en-US" sz="1100" dirty="0"/>
           </a:p>
         </p:txBody>
       </p:sp>
@@ -11769,8 +11811,8 @@
         </p:nvSpPr>
         <p:spPr>
           <a:xfrm>
-            <a:off x="4590288" y="3246120"/>
-            <a:ext cx="3291840" cy="0"/>
+            <a:off x="3474720" y="3200400"/>
+            <a:ext cx="2395728" cy="0"/>
           </a:xfrm>
           <a:prstGeom prst="line">
             <a:avLst/>
@@ -11792,24 +11834,24 @@
         </p:nvSpPr>
         <p:spPr>
           <a:xfrm>
-            <a:off x="4590288" y="3337560"/>
-            <a:ext cx="3291840" cy="365760"/>
-          </a:xfrm>
-          <a:prstGeom prst="rect">
-            <a:avLst/>
-          </a:prstGeom>
-          <a:noFill/>
-          <a:ln/>
-        </p:spPr>
-        <p:txBody>
-          <a:bodyPr wrap="square" rtlCol="0" anchor="ctr"/>
-          <a:lstStyle/>
-          <a:p>
-            <a:pPr indent="0" marL="0">
-              <a:buNone/>
-            </a:pPr>
-            <a:r>
-              <a:rPr lang="en-US" sz="1300" b="1" dirty="0">
+            <a:off x="3474720" y="3291840"/>
+            <a:ext cx="2395728" cy="365760"/>
+          </a:xfrm>
+          <a:prstGeom prst="rect">
+            <a:avLst/>
+          </a:prstGeom>
+          <a:noFill/>
+          <a:ln/>
+        </p:spPr>
+        <p:txBody>
+          <a:bodyPr wrap="square" rtlCol="0" anchor="ctr"/>
+          <a:lstStyle/>
+          <a:p>
+            <a:pPr indent="0" marL="0">
+              <a:buNone/>
+            </a:pPr>
+            <a:r>
+              <a:rPr lang="en-US" sz="1200" b="1" dirty="0">
                 <a:solidFill>
                   <a:srgbClr val="CADCFC"/>
                 </a:solidFill>
@@ -11819,7 +11861,7 @@
               </a:rPr>
               <a:t>→ FECHA</a:t>
             </a:r>
-            <a:endParaRPr lang="en-US" sz="1300" dirty="0"/>
+            <a:endParaRPr lang="en-US" sz="1200" dirty="0"/>
           </a:p>
         </p:txBody>
       </p:sp>
@@ -11831,24 +11873,24 @@
         </p:nvSpPr>
         <p:spPr>
           <a:xfrm>
-            <a:off x="4590288" y="3749040"/>
-            <a:ext cx="3291840" cy="1188720"/>
-          </a:xfrm>
-          <a:prstGeom prst="rect">
-            <a:avLst/>
-          </a:prstGeom>
-          <a:noFill/>
-          <a:ln/>
-        </p:spPr>
-        <p:txBody>
-          <a:bodyPr wrap="square" rtlCol="0" anchor="ctr"/>
-          <a:lstStyle/>
-          <a:p>
-            <a:pPr indent="0" marL="0">
-              <a:buNone/>
-            </a:pPr>
-            <a:r>
-              <a:rPr lang="en-US" sz="1200" dirty="0">
+            <a:off x="3474720" y="3703320"/>
+            <a:ext cx="2395728" cy="1234440"/>
+          </a:xfrm>
+          <a:prstGeom prst="rect">
+            <a:avLst/>
+          </a:prstGeom>
+          <a:noFill/>
+          <a:ln/>
+        </p:spPr>
+        <p:txBody>
+          <a:bodyPr wrap="square" rtlCol="0" anchor="ctr"/>
+          <a:lstStyle/>
+          <a:p>
+            <a:pPr indent="0" marL="0">
+              <a:buNone/>
+            </a:pPr>
+            <a:r>
+              <a:rPr lang="en-US" sz="1100" dirty="0">
                 <a:solidFill>
                   <a:srgbClr val="CADCFC"/>
                 </a:solidFill>
@@ -11856,9 +11898,9 @@
                 <a:ea typeface="Calibri" pitchFamily="34" charset="-122"/>
                 <a:cs typeface="Calibri" pitchFamily="34" charset="-120"/>
               </a:rPr>
-              <a:t>Há um caminho ótimo cujo último passo é estrada — manter o trem é redundante.</a:t>
-            </a:r>
-            <a:endParaRPr lang="en-US" sz="1200" dirty="0"/>
+              <a:t>Há um caminho ótimo só por estradas — trem redundante.</a:t>
+            </a:r>
+            <a:endParaRPr lang="en-US" sz="1100" dirty="0"/>
           </a:p>
         </p:txBody>
       </p:sp>
@@ -11870,8 +11912,8 @@
         </p:nvSpPr>
         <p:spPr>
           <a:xfrm>
-            <a:off x="8266176" y="2240280"/>
-            <a:ext cx="3712464" cy="2743200"/>
+            <a:off x="6126480" y="2240280"/>
+            <a:ext cx="2761488" cy="2743200"/>
           </a:xfrm>
           <a:prstGeom prst="roundRect">
             <a:avLst>
@@ -11897,24 +11939,24 @@
         </p:nvSpPr>
         <p:spPr>
           <a:xfrm>
-            <a:off x="8494776" y="2331720"/>
-            <a:ext cx="3291840" cy="411480"/>
-          </a:xfrm>
-          <a:prstGeom prst="rect">
-            <a:avLst/>
-          </a:prstGeom>
-          <a:noFill/>
-          <a:ln/>
-        </p:spPr>
-        <p:txBody>
-          <a:bodyPr wrap="square" rtlCol="0" anchor="ctr"/>
-          <a:lstStyle/>
-          <a:p>
-            <a:pPr indent="0" marL="0">
-              <a:buNone/>
-            </a:pPr>
-            <a:r>
-              <a:rPr lang="en-US" sz="1600" b="1" dirty="0">
+            <a:off x="6309360" y="2331720"/>
+            <a:ext cx="2395728" cy="365760"/>
+          </a:xfrm>
+          <a:prstGeom prst="rect">
+            <a:avLst/>
+          </a:prstGeom>
+          <a:noFill/>
+          <a:ln/>
+        </p:spPr>
+        <p:txBody>
+          <a:bodyPr wrap="square" rtlCol="0" anchor="ctr"/>
+          <a:lstStyle/>
+          <a:p>
+            <a:pPr indent="0" marL="0">
+              <a:buNone/>
+            </a:pPr>
+            <a:r>
+              <a:rPr lang="en-US" sz="1400" b="1" dirty="0">
                 <a:solidFill>
                   <a:srgbClr val="F9E795"/>
                 </a:solidFill>
@@ -11924,7 +11966,7 @@
               </a:rPr>
               <a:t>Trem essencial</a:t>
             </a:r>
-            <a:endParaRPr lang="en-US" sz="1600" dirty="0"/>
+            <a:endParaRPr lang="en-US" sz="1400" dirty="0"/>
           </a:p>
         </p:txBody>
       </p:sp>
@@ -11936,24 +11978,24 @@
         </p:nvSpPr>
         <p:spPr>
           <a:xfrm>
-            <a:off x="8494776" y="2788920"/>
-            <a:ext cx="3291840" cy="365760"/>
-          </a:xfrm>
-          <a:prstGeom prst="rect">
-            <a:avLst/>
-          </a:prstGeom>
-          <a:noFill/>
-          <a:ln/>
-        </p:spPr>
-        <p:txBody>
-          <a:bodyPr wrap="square" rtlCol="0" anchor="ctr"/>
-          <a:lstStyle/>
-          <a:p>
-            <a:pPr indent="0" marL="0">
-              <a:buNone/>
-            </a:pPr>
-            <a:r>
-              <a:rPr lang="en-US" sz="1200" dirty="0">
+            <a:off x="6309360" y="2743200"/>
+            <a:ext cx="2395728" cy="365760"/>
+          </a:xfrm>
+          <a:prstGeom prst="rect">
+            <a:avLst/>
+          </a:prstGeom>
+          <a:noFill/>
+          <a:ln/>
+        </p:spPr>
+        <p:txBody>
+          <a:bodyPr wrap="square" rtlCol="0" anchor="ctr"/>
+          <a:lstStyle/>
+          <a:p>
+            <a:pPr indent="0" marL="0">
+              <a:buNone/>
+            </a:pPr>
+            <a:r>
+              <a:rPr lang="en-US" sz="1100" dirty="0">
                 <a:solidFill>
                   <a:srgbClr val="FFFFFF"/>
                 </a:solidFill>
@@ -11961,9 +12003,9 @@
                 <a:ea typeface="Consolas" pitchFamily="34" charset="-122"/>
                 <a:cs typeface="Consolas" pitchFamily="34" charset="-120"/>
               </a:rPr>
-              <a:t>y = dist[s]  e  ¬via_estrada[s]</a:t>
-            </a:r>
-            <a:endParaRPr lang="en-US" sz="1200" dirty="0"/>
+              <a:t>y = dist[s] e ¬via_estrada[s]</a:t>
+            </a:r>
+            <a:endParaRPr lang="en-US" sz="1100" dirty="0"/>
           </a:p>
         </p:txBody>
       </p:sp>
@@ -11975,8 +12017,8 @@
         </p:nvSpPr>
         <p:spPr>
           <a:xfrm>
-            <a:off x="8494776" y="3246120"/>
-            <a:ext cx="3291840" cy="0"/>
+            <a:off x="6309360" y="3200400"/>
+            <a:ext cx="2395728" cy="0"/>
           </a:xfrm>
           <a:prstGeom prst="line">
             <a:avLst/>
@@ -11998,24 +12040,24 @@
         </p:nvSpPr>
         <p:spPr>
           <a:xfrm>
-            <a:off x="8494776" y="3337560"/>
-            <a:ext cx="3291840" cy="365760"/>
-          </a:xfrm>
-          <a:prstGeom prst="rect">
-            <a:avLst/>
-          </a:prstGeom>
-          <a:noFill/>
-          <a:ln/>
-        </p:spPr>
-        <p:txBody>
-          <a:bodyPr wrap="square" rtlCol="0" anchor="ctr"/>
-          <a:lstStyle/>
-          <a:p>
-            <a:pPr indent="0" marL="0">
-              <a:buNone/>
-            </a:pPr>
-            <a:r>
-              <a:rPr lang="en-US" sz="1300" b="1" dirty="0">
+            <a:off x="6309360" y="3291840"/>
+            <a:ext cx="2395728" cy="365760"/>
+          </a:xfrm>
+          <a:prstGeom prst="rect">
+            <a:avLst/>
+          </a:prstGeom>
+          <a:noFill/>
+          <a:ln/>
+        </p:spPr>
+        <p:txBody>
+          <a:bodyPr wrap="square" rtlCol="0" anchor="ctr"/>
+          <a:lstStyle/>
+          <a:p>
+            <a:pPr indent="0" marL="0">
+              <a:buNone/>
+            </a:pPr>
+            <a:r>
+              <a:rPr lang="en-US" sz="1200" b="1" dirty="0">
                 <a:solidFill>
                   <a:srgbClr val="F9E795"/>
                 </a:solidFill>
@@ -12023,9 +12065,9 @@
                 <a:ea typeface="Calibri" pitchFamily="34" charset="-122"/>
                 <a:cs typeface="Calibri" pitchFamily="34" charset="-120"/>
               </a:rPr>
-              <a:t>→ mantém 1, fecha duplicatas</a:t>
-            </a:r>
-            <a:endParaRPr lang="en-US" sz="1300" dirty="0"/>
+              <a:t>→ MANTÉM 1</a:t>
+            </a:r>
+            <a:endParaRPr lang="en-US" sz="1200" dirty="0"/>
           </a:p>
         </p:txBody>
       </p:sp>
@@ -12037,24 +12079,24 @@
         </p:nvSpPr>
         <p:spPr>
           <a:xfrm>
-            <a:off x="8494776" y="3749040"/>
-            <a:ext cx="3291840" cy="1188720"/>
-          </a:xfrm>
-          <a:prstGeom prst="rect">
-            <a:avLst/>
-          </a:prstGeom>
-          <a:noFill/>
-          <a:ln/>
-        </p:spPr>
-        <p:txBody>
-          <a:bodyPr wrap="square" rtlCol="0" anchor="ctr"/>
-          <a:lstStyle/>
-          <a:p>
-            <a:pPr indent="0" marL="0">
-              <a:buNone/>
-            </a:pPr>
-            <a:r>
-              <a:rPr lang="en-US" sz="1200" dirty="0">
+            <a:off x="6309360" y="3703320"/>
+            <a:ext cx="2395728" cy="1234440"/>
+          </a:xfrm>
+          <a:prstGeom prst="rect">
+            <a:avLst/>
+          </a:prstGeom>
+          <a:noFill/>
+          <a:ln/>
+        </p:spPr>
+        <p:txBody>
+          <a:bodyPr wrap="square" rtlCol="0" anchor="ctr"/>
+          <a:lstStyle/>
+          <a:p>
+            <a:pPr indent="0" marL="0">
+              <a:buNone/>
+            </a:pPr>
+            <a:r>
+              <a:rPr lang="en-US" sz="1100" dirty="0">
                 <a:solidFill>
                   <a:srgbClr val="CADCFC"/>
                 </a:solidFill>
@@ -12062,7 +12104,174 @@
                 <a:ea typeface="Calibri" pitchFamily="34" charset="-122"/>
                 <a:cs typeface="Calibri" pitchFamily="34" charset="-120"/>
               </a:rPr>
-              <a:t>Sem trem, dist[s] aumentaria. Mantém-se exatamente um trem com esse custo.</a:t>
+              <a:t>Sem trem, dist[s] aumentaria. Duplicatas são fechadas.</a:t>
+            </a:r>
+            <a:endParaRPr lang="en-US" sz="1100" dirty="0"/>
+          </a:p>
+        </p:txBody>
+      </p:sp>
+      <p:sp>
+        <p:nvSpPr>
+          <p:cNvPr id="23" name="Shape 21"/>
+          <p:cNvSpPr/>
+          <p:nvPr/>
+        </p:nvSpPr>
+        <p:spPr>
+          <a:xfrm>
+            <a:off x="8961120" y="2240280"/>
+            <a:ext cx="2761488" cy="2743200"/>
+          </a:xfrm>
+          <a:prstGeom prst="roundRect">
+            <a:avLst>
+              <a:gd name="adj" fmla="val 2667"/>
+            </a:avLst>
+          </a:prstGeom>
+          <a:solidFill>
+            <a:srgbClr val="0F1638"/>
+          </a:solidFill>
+          <a:ln w="25400">
+            <a:solidFill>
+              <a:srgbClr val="8A93B8"/>
+            </a:solidFill>
+            <a:prstDash val="solid"/>
+          </a:ln>
+        </p:spPr>
+      </p:sp>
+      <p:sp>
+        <p:nvSpPr>
+          <p:cNvPr id="24" name="Text 22"/>
+          <p:cNvSpPr/>
+          <p:nvPr/>
+        </p:nvSpPr>
+        <p:spPr>
+          <a:xfrm>
+            <a:off x="9144000" y="2331720"/>
+            <a:ext cx="2395728" cy="365760"/>
+          </a:xfrm>
+          <a:prstGeom prst="rect">
+            <a:avLst/>
+          </a:prstGeom>
+          <a:noFill/>
+          <a:ln/>
+        </p:spPr>
+        <p:txBody>
+          <a:bodyPr wrap="square" rtlCol="0" anchor="ctr"/>
+          <a:lstStyle/>
+          <a:p>
+            <a:pPr indent="0" marL="0">
+              <a:buNone/>
+            </a:pPr>
+            <a:r>
+              <a:rPr lang="en-US" sz="1400" b="1" dirty="0">
+                <a:solidFill>
+                  <a:srgbClr val="8A93B8"/>
+                </a:solidFill>
+                <a:latin typeface="Georgia" pitchFamily="34" charset="0"/>
+                <a:ea typeface="Georgia" pitchFamily="34" charset="-122"/>
+                <a:cs typeface="Georgia" pitchFamily="34" charset="-120"/>
+              </a:rPr>
+              <a:t>Caso impossível</a:t>
+            </a:r>
+            <a:endParaRPr lang="en-US" sz="1400" dirty="0"/>
+          </a:p>
+        </p:txBody>
+      </p:sp>
+      <p:sp>
+        <p:nvSpPr>
+          <p:cNvPr id="25" name="Text 23"/>
+          <p:cNvSpPr/>
+          <p:nvPr/>
+        </p:nvSpPr>
+        <p:spPr>
+          <a:xfrm>
+            <a:off x="9144000" y="2743200"/>
+            <a:ext cx="2395728" cy="365760"/>
+          </a:xfrm>
+          <a:prstGeom prst="rect">
+            <a:avLst/>
+          </a:prstGeom>
+          <a:noFill/>
+          <a:ln/>
+        </p:spPr>
+        <p:txBody>
+          <a:bodyPr wrap="square" rtlCol="0" anchor="ctr"/>
+          <a:lstStyle/>
+          <a:p>
+            <a:pPr indent="0" marL="0">
+              <a:buNone/>
+            </a:pPr>
+            <a:r>
+              <a:rPr lang="en-US" sz="1100" dirty="0">
+                <a:solidFill>
+                  <a:srgbClr val="FFFFFF"/>
+                </a:solidFill>
+                <a:latin typeface="Consolas" pitchFamily="34" charset="0"/>
+                <a:ea typeface="Consolas" pitchFamily="34" charset="-122"/>
+                <a:cs typeface="Consolas" pitchFamily="34" charset="-120"/>
+              </a:rPr>
+              <a:t>y &lt; dist[s]</a:t>
+            </a:r>
+            <a:endParaRPr lang="en-US" sz="1100" dirty="0"/>
+          </a:p>
+        </p:txBody>
+      </p:sp>
+      <p:sp>
+        <p:nvSpPr>
+          <p:cNvPr id="26" name="Shape 24"/>
+          <p:cNvSpPr/>
+          <p:nvPr/>
+        </p:nvSpPr>
+        <p:spPr>
+          <a:xfrm>
+            <a:off x="9144000" y="3200400"/>
+            <a:ext cx="2395728" cy="0"/>
+          </a:xfrm>
+          <a:prstGeom prst="line">
+            <a:avLst/>
+          </a:prstGeom>
+          <a:noFill/>
+          <a:ln w="12700">
+            <a:solidFill>
+              <a:srgbClr val="8A93B8"/>
+            </a:solidFill>
+            <a:prstDash val="solid"/>
+          </a:ln>
+        </p:spPr>
+      </p:sp>
+      <p:sp>
+        <p:nvSpPr>
+          <p:cNvPr id="27" name="Text 25"/>
+          <p:cNvSpPr/>
+          <p:nvPr/>
+        </p:nvSpPr>
+        <p:spPr>
+          <a:xfrm>
+            <a:off x="9144000" y="3291840"/>
+            <a:ext cx="2395728" cy="365760"/>
+          </a:xfrm>
+          <a:prstGeom prst="rect">
+            <a:avLst/>
+          </a:prstGeom>
+          <a:noFill/>
+          <a:ln/>
+        </p:spPr>
+        <p:txBody>
+          <a:bodyPr wrap="square" rtlCol="0" anchor="ctr"/>
+          <a:lstStyle/>
+          <a:p>
+            <a:pPr indent="0" marL="0">
+              <a:buNone/>
+            </a:pPr>
+            <a:r>
+              <a:rPr lang="en-US" sz="1200" b="1" dirty="0">
+                <a:solidFill>
+                  <a:srgbClr val="8A93B8"/>
+                </a:solidFill>
+                <a:latin typeface="Calibri" pitchFamily="34" charset="0"/>
+                <a:ea typeface="Calibri" pitchFamily="34" charset="-122"/>
+                <a:cs typeface="Calibri" pitchFamily="34" charset="-120"/>
+              </a:rPr>
+              <a:t>→ —</a:t>
             </a:r>
             <a:endParaRPr lang="en-US" sz="1200" dirty="0"/>
           </a:p>
@@ -12070,7 +12279,46 @@
       </p:sp>
       <p:sp>
         <p:nvSpPr>
-          <p:cNvPr id="23" name="Shape 21"/>
+          <p:cNvPr id="28" name="Text 26"/>
+          <p:cNvSpPr/>
+          <p:nvPr/>
+        </p:nvSpPr>
+        <p:spPr>
+          <a:xfrm>
+            <a:off x="9144000" y="3703320"/>
+            <a:ext cx="2395728" cy="1234440"/>
+          </a:xfrm>
+          <a:prstGeom prst="rect">
+            <a:avLst/>
+          </a:prstGeom>
+          <a:noFill/>
+          <a:ln/>
+        </p:spPr>
+        <p:txBody>
+          <a:bodyPr wrap="square" rtlCol="0" anchor="ctr"/>
+          <a:lstStyle/>
+          <a:p>
+            <a:pPr indent="0" marL="0">
+              <a:buNone/>
+            </a:pPr>
+            <a:r>
+              <a:rPr lang="en-US" sz="1100" dirty="0">
+                <a:solidFill>
+                  <a:srgbClr val="CADCFC"/>
+                </a:solidFill>
+                <a:latin typeface="Calibri" pitchFamily="34" charset="0"/>
+                <a:ea typeface="Calibri" pitchFamily="34" charset="-122"/>
+                <a:cs typeface="Calibri" pitchFamily="34" charset="-120"/>
+              </a:rPr>
+              <a:t>Não ocorre: o trem já entrou no Dijkstra e fixaria dist[s].</a:t>
+            </a:r>
+            <a:endParaRPr lang="en-US" sz="1100" dirty="0"/>
+          </a:p>
+        </p:txBody>
+      </p:sp>
+      <p:sp>
+        <p:nvSpPr>
+          <p:cNvPr id="29" name="Shape 27"/>
           <p:cNvSpPr/>
           <p:nvPr/>
         </p:nvSpPr>
@@ -12097,7 +12345,7 @@
       </p:sp>
       <p:sp>
         <p:nvSpPr>
-          <p:cNvPr id="24" name="Text 22"/>
+          <p:cNvPr id="30" name="Text 28"/>
           <p:cNvSpPr/>
           <p:nvPr/>
         </p:nvSpPr>
@@ -12136,7 +12384,7 @@
       </p:sp>
       <p:sp>
         <p:nvSpPr>
-          <p:cNvPr id="25" name="Text 23"/>
+          <p:cNvPr id="31" name="Text 29"/>
           <p:cNvSpPr/>
           <p:nvPr/>
         </p:nvSpPr>
@@ -12289,7 +12537,7 @@
       </p:sp>
       <p:sp>
         <p:nvSpPr>
-          <p:cNvPr id="26" name="Shape 24"/>
+          <p:cNvPr id="32" name="Shape 30"/>
           <p:cNvSpPr/>
           <p:nvPr/>
         </p:nvSpPr>
@@ -12314,7 +12562,7 @@
       </p:sp>
       <p:sp>
         <p:nvSpPr>
-          <p:cNvPr id="27" name="Text 25"/>
+          <p:cNvPr id="33" name="Text 31"/>
           <p:cNvSpPr/>
           <p:nvPr/>
         </p:nvSpPr>
@@ -12353,7 +12601,7 @@
       </p:sp>
       <p:sp>
         <p:nvSpPr>
-          <p:cNvPr id="28" name="Text 26"/>
+          <p:cNvPr id="34" name="Text 32"/>
           <p:cNvSpPr/>
           <p:nvPr/>
         </p:nvSpPr>

</xml_diff>